<commit_message>
docs(pptx): correct seniority (slide 8) and leave counts (slide 12)
Slide 8 read TENURE=0 as 'less than one year of seniority' (720, 49%); the real figure is 55 employees (4%), median seniority 10.9 years. Slide 12 leave counts now cover all 2,740 employees.
</commit_message>
<xml_diff>
--- a/Projet_EDA_BI_RH.pptx
+++ b/Projet_EDA_BI_RH.pptx
@@ -5854,7 +5854,7 @@
                           <a:ea typeface="IBM Plex Sans" pitchFamily="34" charset="-122"/>
                           <a:cs typeface="IBM Plex Sans" pitchFamily="34" charset="-120"/>
                         </a:rPr>
-                        <a:t>716</a:t>
+                        <a:t>718</a:t>
                       </a:r>
                       <a:endParaRPr lang="en-US" sz="1200" dirty="0">
                         <a:latin typeface="IBM Plex Sans" charset="0"/>
@@ -5997,7 +5997,7 @@
                           <a:ea typeface="IBM Plex Sans" pitchFamily="34" charset="-122"/>
                           <a:cs typeface="IBM Plex Sans" pitchFamily="34" charset="-120"/>
                         </a:rPr>
-                        <a:t>696</a:t>
+                        <a:t>698</a:t>
                       </a:r>
                       <a:endParaRPr lang="en-US" sz="1200" dirty="0">
                         <a:latin typeface="IBM Plex Sans" charset="0"/>
@@ -6140,7 +6140,7 @@
                           <a:ea typeface="IBM Plex Sans" pitchFamily="34" charset="-122"/>
                           <a:cs typeface="IBM Plex Sans" pitchFamily="34" charset="-120"/>
                         </a:rPr>
-                        <a:t>674</a:t>
+                        <a:t>675</a:t>
                       </a:r>
                       <a:endParaRPr lang="en-US" sz="1200" dirty="0">
                         <a:latin typeface="IBM Plex Sans" charset="0"/>
@@ -6283,7 +6283,7 @@
                           <a:ea typeface="IBM Plex Sans" pitchFamily="34" charset="-122"/>
                           <a:cs typeface="IBM Plex Sans" pitchFamily="34" charset="-120"/>
                         </a:rPr>
-                        <a:t>648</a:t>
+                        <a:t>649</a:t>
                       </a:r>
                       <a:endParaRPr lang="en-US" sz="1200" dirty="0">
                         <a:latin typeface="IBM Plex Sans" charset="0"/>
@@ -34449,7 +34449,7 @@
                 <a:ea typeface="Space Grotesk" pitchFamily="34" charset="-122"/>
                 <a:cs typeface="Space Grotesk" pitchFamily="34" charset="-120"/>
               </a:rPr>
-              <a:t>Un effectif jeune et contractuel</a:t>
+              <a:t>Un effectif ancien mais contractuel</a:t>
             </a:r>
             <a:endParaRPr lang="en-US" sz="3200" dirty="0"/>
           </a:p>
@@ -34693,7 +34693,7 @@
                 <a:ea typeface="Space Grotesk" pitchFamily="34" charset="-122"/>
                 <a:cs typeface="Space Grotesk" pitchFamily="34" charset="-120"/>
               </a:rPr>
-              <a:t>49 %</a:t>
+              <a:t>4 %</a:t>
             </a:r>
             <a:endParaRPr lang="en-US" sz="6000" dirty="0"/>
           </a:p>
@@ -34781,7 +34781,7 @@
                 <a:ea typeface="IBM Plex Sans" pitchFamily="34" charset="-122"/>
                 <a:cs typeface="IBM Plex Sans" pitchFamily="34" charset="-120"/>
               </a:rPr>
-              <a:t>720 sur 1 461 employés techniques</a:t>
+              <a:t>55 sur 1 461 · médiane 10,9 ans</a:t>
             </a:r>
             <a:endParaRPr lang="en-US" sz="1200" dirty="0"/>
           </a:p>

</xml_diff>